<commit_message>
Integrated Hugging Face dataset for dynamic Line/Length/Shot Vulnerability Matrix in UI and PDF; Upgraded PyTorch Tensor to 59D
</commit_message>
<xml_diff>
--- a/DeepSequence_Final_Presentation_V3.pptx
+++ b/DeepSequence_Final_Presentation_V3.pptx
@@ -8,8 +8,9 @@
     <p:sldId id="256" r:id="rId2"/>
     <p:sldId id="257" r:id="rId3"/>
     <p:sldId id="258" r:id="rId4"/>
-    <p:sldId id="259" r:id="rId5"/>
-    <p:sldId id="260" r:id="rId6"/>
+    <p:sldId id="261" r:id="rId5"/>
+    <p:sldId id="259" r:id="rId6"/>
+    <p:sldId id="260" r:id="rId7"/>
   </p:sldIdLst>
   <p:sldSz cx="9144000" cy="6858000" type="screen4x3"/>
   <p:notesSz cx="6858000" cy="9144000"/>
@@ -878,7 +879,7 @@
 <dgm:dataModel xmlns:dgm="http://schemas.openxmlformats.org/drawingml/2006/diagram" xmlns:a="http://schemas.openxmlformats.org/drawingml/2006/main">
   <dgm:ptLst>
     <dgm:pt modelId="{946171C2-E533-4441-B41B-54CC7D44E16D}" type="doc">
-      <dgm:prSet loTypeId="urn:microsoft.com/office/officeart/2005/8/layout/hList1" loCatId="list" qsTypeId="urn:microsoft.com/office/officeart/2005/8/quickstyle/simple1#123" qsCatId="simple" csTypeId="urn:microsoft.com/office/officeart/2005/8/colors/accent1_2#78" csCatId="accent1"/>
+      <dgm:prSet loTypeId="urn:microsoft.com/office/officeart/2005/8/layout/hList1" loCatId="list" qsTypeId="urn:microsoft.com/office/officeart/2005/8/quickstyle/simple1#123" qsCatId="simple" csTypeId="urn:microsoft.com/office/officeart/2005/8/colors/accent1_2#78" csCatId="accent1" phldr="1"/>
       <dgm:spPr/>
       <dgm:t>
         <a:bodyPr/>
@@ -896,8 +897,8 @@
         <a:lstStyle/>
         <a:p>
           <a:r>
-            <a:rPr lang="en-US"/>
-            <a:t>The Flaw in Traditional Analytics:</a:t>
+            <a:rPr lang="en-US" dirty="0"/>
+            <a:t>The Problem of Traditional Analytics:</a:t>
           </a:r>
         </a:p>
       </dgm:t>
@@ -932,7 +933,7 @@
         <a:lstStyle/>
         <a:p>
           <a:r>
-            <a:rPr lang="en-US"/>
+            <a:rPr lang="en-US" dirty="0"/>
             <a:t>Static career averages fail to capture live match momentum.</a:t>
           </a:r>
         </a:p>
@@ -1100,7 +1101,7 @@
       </dgm:prSet>
       <dgm:spPr/>
     </dgm:pt>
-    <dgm:pt modelId="{ABC27C23-4E49-44B6-94CE-B613993D8A46}" type="pres">
+    <dgm:pt modelId="{C71EB59B-68D6-4302-8A17-1912458F545B}" type="pres">
       <dgm:prSet presAssocID="{2CCAA83D-E403-45D1-ADE8-28C2B730F3B3}" presName="space" presStyleCnt="0"/>
       <dgm:spPr/>
     </dgm:pt>
@@ -1129,23 +1130,23 @@
   </dgm:ptLst>
   <dgm:cxnLst>
     <dgm:cxn modelId="{48396201-B363-41CE-92B8-F296808BECEB}" type="presOf" srcId="{946171C2-E533-4441-B41B-54CC7D44E16D}" destId="{2B917D0A-1BE1-4CCA-94A4-696B3BE20A17}" srcOrd="0" destOrd="0" presId="urn:microsoft.com/office/officeart/2005/8/layout/hList1"/>
+    <dgm:cxn modelId="{96137E25-697A-4EB8-9E96-94ABA5BB8D2B}" type="presOf" srcId="{D792C89B-BBE2-44B0-A0D3-99C4872C535C}" destId="{9BEED827-96B1-4C9D-82C5-F8BBC2EF983F}" srcOrd="0" destOrd="0" presId="urn:microsoft.com/office/officeart/2005/8/layout/hList1"/>
     <dgm:cxn modelId="{5CA81B43-B32B-48EA-B0D6-CFF8F2804BDF}" srcId="{7864F96E-96EC-4E8C-AF3D-2639CDB22845}" destId="{D139D337-0B6D-45ED-85DA-D12EA10923E9}" srcOrd="0" destOrd="0" parTransId="{012B4436-CB23-46D1-B043-1B9A559E5CF5}" sibTransId="{7A72555F-B239-4D8F-94FD-0F679B2DCF84}"/>
     <dgm:cxn modelId="{F01BB667-7F6F-4E09-A3E1-77F2FACBB6A2}" srcId="{D792C89B-BBE2-44B0-A0D3-99C4872C535C}" destId="{9836A323-DBB1-4FE0-BFF5-06D36EFA8FB4}" srcOrd="0" destOrd="0" parTransId="{371E52EA-017F-4603-AA00-675AAEE1F543}" sibTransId="{BC9FE9E4-4D86-4C65-BA1D-3D82770753F3}"/>
-    <dgm:cxn modelId="{F2B6EB67-8764-4E19-B800-F0F430A0AD36}" type="presOf" srcId="{D139D337-0B6D-45ED-85DA-D12EA10923E9}" destId="{1183C65C-7C56-4807-A97C-5A53DD9EE3C0}" srcOrd="0" destOrd="0" presId="urn:microsoft.com/office/officeart/2005/8/layout/hList1"/>
-    <dgm:cxn modelId="{6A67A07B-BA64-4642-A66D-B55113F4E37A}" type="presOf" srcId="{D792C89B-BBE2-44B0-A0D3-99C4872C535C}" destId="{9BEED827-96B1-4C9D-82C5-F8BBC2EF983F}" srcOrd="0" destOrd="0" presId="urn:microsoft.com/office/officeart/2005/8/layout/hList1"/>
-    <dgm:cxn modelId="{5379BBAA-55AB-43E6-A8CC-6FCD6A4774C3}" type="presOf" srcId="{7C5FBBDB-F5A7-47CD-8C7C-A3F991C6C06F}" destId="{1183C65C-7C56-4807-A97C-5A53DD9EE3C0}" srcOrd="0" destOrd="1" presId="urn:microsoft.com/office/officeart/2005/8/layout/hList1"/>
+    <dgm:cxn modelId="{04A91A78-3ABE-4AA5-ABA1-E8ADAECD37AA}" type="presOf" srcId="{D139D337-0B6D-45ED-85DA-D12EA10923E9}" destId="{1183C65C-7C56-4807-A97C-5A53DD9EE3C0}" srcOrd="0" destOrd="0" presId="urn:microsoft.com/office/officeart/2005/8/layout/hList1"/>
+    <dgm:cxn modelId="{C4CF2A81-D935-4F85-944A-9C060A5C2547}" type="presOf" srcId="{7C5FBBDB-F5A7-47CD-8C7C-A3F991C6C06F}" destId="{1183C65C-7C56-4807-A97C-5A53DD9EE3C0}" srcOrd="0" destOrd="1" presId="urn:microsoft.com/office/officeart/2005/8/layout/hList1"/>
+    <dgm:cxn modelId="{80B45B9E-1B44-45E9-9B93-4786D6786C36}" type="presOf" srcId="{7864F96E-96EC-4E8C-AF3D-2639CDB22845}" destId="{CD26080D-6248-4845-91A2-41F6479DBC14}" srcOrd="0" destOrd="0" presId="urn:microsoft.com/office/officeart/2005/8/layout/hList1"/>
     <dgm:cxn modelId="{CFFE7ABD-C757-4F5A-9FED-364C2375C8FC}" srcId="{7864F96E-96EC-4E8C-AF3D-2639CDB22845}" destId="{7C5FBBDB-F5A7-47CD-8C7C-A3F991C6C06F}" srcOrd="1" destOrd="0" parTransId="{673B8D9A-4139-44C0-A3FA-7E7B083E9ED0}" sibTransId="{ED3984CB-64DA-40CA-AABF-F6686C03C194}"/>
     <dgm:cxn modelId="{6E2855C4-9D62-4EFE-9616-705B3355E8A3}" srcId="{946171C2-E533-4441-B41B-54CC7D44E16D}" destId="{D792C89B-BBE2-44B0-A0D3-99C4872C535C}" srcOrd="1" destOrd="0" parTransId="{975A3517-734B-458E-8F32-D193AD7D4FB1}" sibTransId="{618C3FED-F82B-423F-A6D4-42D6C54C79B2}"/>
+    <dgm:cxn modelId="{A81D0BC5-E9E3-47C0-ADB3-B944DAE99BF7}" type="presOf" srcId="{9836A323-DBB1-4FE0-BFF5-06D36EFA8FB4}" destId="{7AB2BC13-D988-4DE5-AD8B-4851C4764FCB}" srcOrd="0" destOrd="0" presId="urn:microsoft.com/office/officeart/2005/8/layout/hList1"/>
     <dgm:cxn modelId="{FAB658DB-4206-420A-B330-C11A21189AA8}" srcId="{946171C2-E533-4441-B41B-54CC7D44E16D}" destId="{7864F96E-96EC-4E8C-AF3D-2639CDB22845}" srcOrd="0" destOrd="0" parTransId="{016B0DD0-8AA3-4FDA-8830-04F17340AC16}" sibTransId="{2CCAA83D-E403-45D1-ADE8-28C2B730F3B3}"/>
-    <dgm:cxn modelId="{5252F8F0-AD0C-4FA4-8BB7-27CBD012D6F5}" type="presOf" srcId="{7864F96E-96EC-4E8C-AF3D-2639CDB22845}" destId="{CD26080D-6248-4845-91A2-41F6479DBC14}" srcOrd="0" destOrd="0" presId="urn:microsoft.com/office/officeart/2005/8/layout/hList1"/>
-    <dgm:cxn modelId="{786F67F3-6B40-4F59-9247-AFEBBB315C7F}" type="presOf" srcId="{9836A323-DBB1-4FE0-BFF5-06D36EFA8FB4}" destId="{7AB2BC13-D988-4DE5-AD8B-4851C4764FCB}" srcOrd="0" destOrd="0" presId="urn:microsoft.com/office/officeart/2005/8/layout/hList1"/>
-    <dgm:cxn modelId="{EC4BE5B4-48A3-4D36-B753-A10780C82061}" type="presParOf" srcId="{2B917D0A-1BE1-4CCA-94A4-696B3BE20A17}" destId="{B92C6CED-3916-464E-95B6-490FD5793197}" srcOrd="0" destOrd="0" presId="urn:microsoft.com/office/officeart/2005/8/layout/hList1"/>
-    <dgm:cxn modelId="{96B85458-0D0F-49ED-8E23-E1BD45AE9ED7}" type="presParOf" srcId="{B92C6CED-3916-464E-95B6-490FD5793197}" destId="{CD26080D-6248-4845-91A2-41F6479DBC14}" srcOrd="0" destOrd="0" presId="urn:microsoft.com/office/officeart/2005/8/layout/hList1"/>
-    <dgm:cxn modelId="{1ABF8ABC-5677-4FF3-BC08-2C45662083B5}" type="presParOf" srcId="{B92C6CED-3916-464E-95B6-490FD5793197}" destId="{1183C65C-7C56-4807-A97C-5A53DD9EE3C0}" srcOrd="1" destOrd="0" presId="urn:microsoft.com/office/officeart/2005/8/layout/hList1"/>
-    <dgm:cxn modelId="{8F7FCA5A-9C7A-4B98-9148-48E4F0391E37}" type="presParOf" srcId="{2B917D0A-1BE1-4CCA-94A4-696B3BE20A17}" destId="{ABC27C23-4E49-44B6-94CE-B613993D8A46}" srcOrd="1" destOrd="0" presId="urn:microsoft.com/office/officeart/2005/8/layout/hList1"/>
-    <dgm:cxn modelId="{78962C19-DCC7-4FB3-A16B-B1BD302720D6}" type="presParOf" srcId="{2B917D0A-1BE1-4CCA-94A4-696B3BE20A17}" destId="{94CF3E48-015E-410A-914B-E2B910BD5EF3}" srcOrd="2" destOrd="0" presId="urn:microsoft.com/office/officeart/2005/8/layout/hList1"/>
-    <dgm:cxn modelId="{832ECD3D-3501-4E9D-B222-1BAB2EA94958}" type="presParOf" srcId="{94CF3E48-015E-410A-914B-E2B910BD5EF3}" destId="{9BEED827-96B1-4C9D-82C5-F8BBC2EF983F}" srcOrd="0" destOrd="0" presId="urn:microsoft.com/office/officeart/2005/8/layout/hList1"/>
-    <dgm:cxn modelId="{71775D01-1547-4F07-B4AD-E340D9BC86F9}" type="presParOf" srcId="{94CF3E48-015E-410A-914B-E2B910BD5EF3}" destId="{7AB2BC13-D988-4DE5-AD8B-4851C4764FCB}" srcOrd="1" destOrd="0" presId="urn:microsoft.com/office/officeart/2005/8/layout/hList1"/>
+    <dgm:cxn modelId="{6D0E10E2-96C1-4368-86D7-9B3E7754CA8F}" type="presParOf" srcId="{2B917D0A-1BE1-4CCA-94A4-696B3BE20A17}" destId="{B92C6CED-3916-464E-95B6-490FD5793197}" srcOrd="0" destOrd="0" presId="urn:microsoft.com/office/officeart/2005/8/layout/hList1"/>
+    <dgm:cxn modelId="{4AB4ABD1-3A0C-4D23-B0EE-BFB125687C34}" type="presParOf" srcId="{B92C6CED-3916-464E-95B6-490FD5793197}" destId="{CD26080D-6248-4845-91A2-41F6479DBC14}" srcOrd="0" destOrd="0" presId="urn:microsoft.com/office/officeart/2005/8/layout/hList1"/>
+    <dgm:cxn modelId="{3849F031-AADB-4956-89F5-1766DEEC0368}" type="presParOf" srcId="{B92C6CED-3916-464E-95B6-490FD5793197}" destId="{1183C65C-7C56-4807-A97C-5A53DD9EE3C0}" srcOrd="1" destOrd="0" presId="urn:microsoft.com/office/officeart/2005/8/layout/hList1"/>
+    <dgm:cxn modelId="{7D29685D-11D5-4AC7-8D55-2A0312A8C6FC}" type="presParOf" srcId="{2B917D0A-1BE1-4CCA-94A4-696B3BE20A17}" destId="{C71EB59B-68D6-4302-8A17-1912458F545B}" srcOrd="1" destOrd="0" presId="urn:microsoft.com/office/officeart/2005/8/layout/hList1"/>
+    <dgm:cxn modelId="{E6A76DDE-50BE-4D98-BE1D-253739BFC433}" type="presParOf" srcId="{2B917D0A-1BE1-4CCA-94A4-696B3BE20A17}" destId="{94CF3E48-015E-410A-914B-E2B910BD5EF3}" srcOrd="2" destOrd="0" presId="urn:microsoft.com/office/officeart/2005/8/layout/hList1"/>
+    <dgm:cxn modelId="{0D21C96E-431E-4239-8753-51CFE877DB8A}" type="presParOf" srcId="{94CF3E48-015E-410A-914B-E2B910BD5EF3}" destId="{9BEED827-96B1-4C9D-82C5-F8BBC2EF983F}" srcOrd="0" destOrd="0" presId="urn:microsoft.com/office/officeart/2005/8/layout/hList1"/>
+    <dgm:cxn modelId="{56B5398E-E643-4B54-8490-72A0B9EC843F}" type="presParOf" srcId="{94CF3E48-015E-410A-914B-E2B910BD5EF3}" destId="{7AB2BC13-D988-4DE5-AD8B-4851C4764FCB}" srcOrd="1" destOrd="0" presId="urn:microsoft.com/office/officeart/2005/8/layout/hList1"/>
   </dgm:cxnLst>
   <dgm:bg/>
   <dgm:whole/>
@@ -1232,8 +1233,8 @@
             <a:buNone/>
           </a:pPr>
           <a:r>
-            <a:rPr lang="en-US" sz="1500" kern="1200"/>
-            <a:t>The Flaw in Traditional Analytics:</a:t>
+            <a:rPr lang="en-US" sz="1500" kern="1200" dirty="0"/>
+            <a:t>The Problem of Traditional Analytics:</a:t>
           </a:r>
         </a:p>
       </dsp:txBody>
@@ -1311,7 +1312,7 @@
             <a:buChar char="•"/>
           </a:pPr>
           <a:r>
-            <a:rPr lang="en-US" sz="1500" kern="1200"/>
+            <a:rPr lang="en-US" sz="1500" kern="1200" dirty="0"/>
             <a:t>Static career averages fail to capture live match momentum.</a:t>
           </a:r>
         </a:p>
@@ -2929,7 +2930,7 @@
           <a:p>
             <a:fld id="{5BCAD085-E8A6-8845-BD4E-CB4CCA059FC4}" type="datetimeFigureOut">
               <a:rPr lang="en-US" smtClean="0"/>
-              <a:t>9/4/2026</a:t>
+              <a:t>9/7/2026</a:t>
             </a:fld>
             <a:endParaRPr lang="en-US"/>
           </a:p>
@@ -3097,7 +3098,7 @@
           <a:p>
             <a:fld id="{5BCAD085-E8A6-8845-BD4E-CB4CCA059FC4}" type="datetimeFigureOut">
               <a:rPr lang="en-US" smtClean="0"/>
-              <a:t>9/4/2026</a:t>
+              <a:t>9/7/2026</a:t>
             </a:fld>
             <a:endParaRPr lang="en-US"/>
           </a:p>
@@ -3275,7 +3276,7 @@
           <a:p>
             <a:fld id="{5BCAD085-E8A6-8845-BD4E-CB4CCA059FC4}" type="datetimeFigureOut">
               <a:rPr lang="en-US" smtClean="0"/>
-              <a:t>9/4/2026</a:t>
+              <a:t>9/7/2026</a:t>
             </a:fld>
             <a:endParaRPr lang="en-US"/>
           </a:p>
@@ -3443,7 +3444,7 @@
           <a:p>
             <a:fld id="{5BCAD085-E8A6-8845-BD4E-CB4CCA059FC4}" type="datetimeFigureOut">
               <a:rPr lang="en-US" smtClean="0"/>
-              <a:t>9/4/2026</a:t>
+              <a:t>9/7/2026</a:t>
             </a:fld>
             <a:endParaRPr lang="en-US"/>
           </a:p>
@@ -3688,7 +3689,7 @@
           <a:p>
             <a:fld id="{5BCAD085-E8A6-8845-BD4E-CB4CCA059FC4}" type="datetimeFigureOut">
               <a:rPr lang="en-US" smtClean="0"/>
-              <a:t>9/4/2026</a:t>
+              <a:t>9/7/2026</a:t>
             </a:fld>
             <a:endParaRPr lang="en-US"/>
           </a:p>
@@ -3973,7 +3974,7 @@
           <a:p>
             <a:fld id="{5BCAD085-E8A6-8845-BD4E-CB4CCA059FC4}" type="datetimeFigureOut">
               <a:rPr lang="en-US" smtClean="0"/>
-              <a:t>9/4/2026</a:t>
+              <a:t>9/7/2026</a:t>
             </a:fld>
             <a:endParaRPr lang="en-US"/>
           </a:p>
@@ -4392,7 +4393,7 @@
           <a:p>
             <a:fld id="{5BCAD085-E8A6-8845-BD4E-CB4CCA059FC4}" type="datetimeFigureOut">
               <a:rPr lang="en-US" smtClean="0"/>
-              <a:t>9/4/2026</a:t>
+              <a:t>9/7/2026</a:t>
             </a:fld>
             <a:endParaRPr lang="en-US"/>
           </a:p>
@@ -4509,7 +4510,7 @@
           <a:p>
             <a:fld id="{5BCAD085-E8A6-8845-BD4E-CB4CCA059FC4}" type="datetimeFigureOut">
               <a:rPr lang="en-US" smtClean="0"/>
-              <a:t>9/4/2026</a:t>
+              <a:t>9/7/2026</a:t>
             </a:fld>
             <a:endParaRPr lang="en-US"/>
           </a:p>
@@ -4604,7 +4605,7 @@
           <a:p>
             <a:fld id="{5BCAD085-E8A6-8845-BD4E-CB4CCA059FC4}" type="datetimeFigureOut">
               <a:rPr lang="en-US" smtClean="0"/>
-              <a:t>9/4/2026</a:t>
+              <a:t>9/7/2026</a:t>
             </a:fld>
             <a:endParaRPr lang="en-US"/>
           </a:p>
@@ -4879,7 +4880,7 @@
           <a:p>
             <a:fld id="{5BCAD085-E8A6-8845-BD4E-CB4CCA059FC4}" type="datetimeFigureOut">
               <a:rPr lang="en-US" smtClean="0"/>
-              <a:t>9/4/2026</a:t>
+              <a:t>9/7/2026</a:t>
             </a:fld>
             <a:endParaRPr lang="en-US"/>
           </a:p>
@@ -5131,7 +5132,7 @@
           <a:p>
             <a:fld id="{5BCAD085-E8A6-8845-BD4E-CB4CCA059FC4}" type="datetimeFigureOut">
               <a:rPr lang="en-US" smtClean="0"/>
-              <a:t>9/4/2026</a:t>
+              <a:t>9/7/2026</a:t>
             </a:fld>
             <a:endParaRPr lang="en-US"/>
           </a:p>
@@ -5342,7 +5343,7 @@
           <a:p>
             <a:fld id="{5BCAD085-E8A6-8845-BD4E-CB4CCA059FC4}" type="datetimeFigureOut">
               <a:rPr lang="en-US" smtClean="0"/>
-              <a:t>9/4/2026</a:t>
+              <a:t>9/7/2026</a:t>
             </a:fld>
             <a:endParaRPr lang="en-US"/>
           </a:p>
@@ -5812,6 +5813,7 @@
               <a:rPr lang="en-US" sz="4700"/>
               <a:t>DeepSequence T20I</a:t>
             </a:r>
+            <a:endParaRPr lang="en-US" sz="4700" dirty="0"/>
           </a:p>
         </p:txBody>
       </p:sp>
@@ -5843,8 +5845,34 @@
               </a:lnSpc>
             </a:pPr>
             <a:r>
-              <a:rPr lang="en-US" sz="2200"/>
+              <a:rPr lang="en-US" sz="2200" dirty="0"/>
               <a:t>A Momentum-Aware Predictive Engine for T20 Cricket</a:t>
+            </a:r>
+            <a:br>
+              <a:rPr lang="en-US" sz="2200" dirty="0"/>
+            </a:br>
+            <a:r>
+              <a:rPr lang="en-US" sz="2200" dirty="0"/>
+              <a:t>S M </a:t>
+            </a:r>
+            <a:r>
+              <a:rPr lang="en-US" sz="2200" dirty="0" err="1"/>
+              <a:t>Tazbid</a:t>
+            </a:r>
+            <a:r>
+              <a:rPr lang="en-US" sz="2200" dirty="0"/>
+              <a:t> Siddiqui</a:t>
+            </a:r>
+            <a:br>
+              <a:rPr lang="en-US" sz="2200" dirty="0"/>
+            </a:br>
+            <a:r>
+              <a:rPr lang="en-US" sz="2200" dirty="0" err="1"/>
+              <a:t>Mostofa</a:t>
+            </a:r>
+            <a:r>
+              <a:rPr lang="en-US" sz="2200" dirty="0"/>
+              <a:t> Morshed</a:t>
             </a:r>
           </a:p>
           <a:p>
@@ -5853,18 +5881,7 @@
                 <a:spcPct val="90000"/>
               </a:lnSpc>
             </a:pPr>
-            <a:endParaRPr lang="en-US" sz="2200"/>
-          </a:p>
-          <a:p>
-            <a:pPr algn="l">
-              <a:lnSpc>
-                <a:spcPct val="90000"/>
-              </a:lnSpc>
-            </a:pPr>
-            <a:r>
-              <a:rPr lang="en-US" sz="2200"/>
-              <a:t>Final Presentation</a:t>
-            </a:r>
+            <a:endParaRPr lang="en-US" sz="2200" dirty="0"/>
           </a:p>
         </p:txBody>
       </p:sp>
@@ -6388,70 +6405,6 @@
                                           <p:spTgt spid="3">
                                             <p:txEl>
                                               <p:pRg st="0" end="0"/>
-                                            </p:txEl>
-                                          </p:spTgt>
-                                        </p:tgtEl>
-                                      </p:cBhvr>
-                                    </p:animEffect>
-                                  </p:childTnLst>
-                                </p:cTn>
-                              </p:par>
-                            </p:childTnLst>
-                          </p:cTn>
-                        </p:par>
-                      </p:childTnLst>
-                    </p:cTn>
-                  </p:par>
-                  <p:par>
-                    <p:cTn id="11" fill="hold">
-                      <p:stCondLst>
-                        <p:cond delay="indefinite"/>
-                      </p:stCondLst>
-                      <p:childTnLst>
-                        <p:par>
-                          <p:cTn id="12" fill="hold">
-                            <p:stCondLst>
-                              <p:cond delay="0"/>
-                            </p:stCondLst>
-                            <p:childTnLst>
-                              <p:par>
-                                <p:cTn id="13" presetID="10" presetClass="entr" presetSubtype="0" fill="hold" grpId="0" nodeType="clickEffect">
-                                  <p:stCondLst>
-                                    <p:cond delay="2000"/>
-                                  </p:stCondLst>
-                                  <p:iterate type="lt">
-                                    <p:tmPct val="10000"/>
-                                  </p:iterate>
-                                  <p:childTnLst>
-                                    <p:set>
-                                      <p:cBhvr>
-                                        <p:cTn id="14" dur="1" fill="hold">
-                                          <p:stCondLst>
-                                            <p:cond delay="0"/>
-                                          </p:stCondLst>
-                                        </p:cTn>
-                                        <p:tgtEl>
-                                          <p:spTgt spid="3">
-                                            <p:txEl>
-                                              <p:pRg st="2" end="2"/>
-                                            </p:txEl>
-                                          </p:spTgt>
-                                        </p:tgtEl>
-                                        <p:attrNameLst>
-                                          <p:attrName>style.visibility</p:attrName>
-                                        </p:attrNameLst>
-                                      </p:cBhvr>
-                                      <p:to>
-                                        <p:strVal val="visible"/>
-                                      </p:to>
-                                    </p:set>
-                                    <p:animEffect transition="in" filter="fade">
-                                      <p:cBhvr>
-                                        <p:cTn id="15" dur="400"/>
-                                        <p:tgtEl>
-                                          <p:spTgt spid="3">
-                                            <p:txEl>
-                                              <p:pRg st="2" end="2"/>
                                             </p:txEl>
                                           </p:spTgt>
                                         </p:tgtEl>
@@ -10464,6 +10417,11 @@
           </p:cNvGraphicFramePr>
           <p:nvPr>
             <p:ph idx="1"/>
+            <p:extLst>
+              <p:ext uri="{D42A27DB-BD31-4B8C-83A1-F6EECF244321}">
+                <p14:modId xmlns:p14="http://schemas.microsoft.com/office/powerpoint/2010/main" val="3445018090"/>
+              </p:ext>
+            </p:extLst>
           </p:nvPr>
         </p:nvGraphicFramePr>
         <p:xfrm>
@@ -11052,7 +11010,7 @@
               </a:lnSpc>
             </a:pPr>
             <a:r>
-              <a:rPr lang="en-US" sz="1600"/>
+              <a:rPr lang="en-US" sz="1600" dirty="0"/>
               <a:t>Data Ingestion:</a:t>
             </a:r>
           </a:p>
@@ -11063,8 +11021,16 @@
               </a:lnSpc>
             </a:pPr>
             <a:r>
-              <a:rPr lang="en-US" sz="1600"/>
-              <a:t>Batch parser engine cleanly structures 1.2 million nested JSON deliveries from Cricsheet.</a:t>
+              <a:rPr lang="en-US" sz="1600" dirty="0"/>
+              <a:t>Batch parser engine cleanly structures 1.2 million nested JSON deliveries from </a:t>
+            </a:r>
+            <a:r>
+              <a:rPr lang="en-US" sz="1600" dirty="0" err="1"/>
+              <a:t>Cricsheet</a:t>
+            </a:r>
+            <a:r>
+              <a:rPr lang="en-US" sz="1600" dirty="0"/>
+              <a:t>.</a:t>
             </a:r>
           </a:p>
           <a:p>
@@ -11074,7 +11040,7 @@
               </a:lnSpc>
             </a:pPr>
             <a:r>
-              <a:rPr lang="en-US" sz="1600"/>
+              <a:rPr lang="en-US" sz="1600" dirty="0"/>
               <a:t>Model Architecture:</a:t>
             </a:r>
           </a:p>
@@ -11085,8 +11051,12 @@
               </a:lnSpc>
             </a:pPr>
             <a:r>
-              <a:rPr lang="en-US" sz="1600"/>
-              <a:t>PyTorch LSTM models reading up to a 12-ball rolling sequence.</a:t>
+              <a:rPr lang="en-US" sz="1600" dirty="0" err="1"/>
+              <a:t>PyTorch</a:t>
+            </a:r>
+            <a:r>
+              <a:rPr lang="en-US" sz="1600" dirty="0"/>
+              <a:t> LSTM models reading up to a 12-ball rolling sequence.</a:t>
             </a:r>
           </a:p>
           <a:p>
@@ -11096,7 +11066,7 @@
               </a:lnSpc>
             </a:pPr>
             <a:r>
-              <a:rPr lang="en-US" sz="1600"/>
+              <a:rPr lang="en-US" sz="1600" dirty="0"/>
               <a:t>NLP Python regex scripts extract ball Line and Length from unstructured text commentary.</a:t>
             </a:r>
           </a:p>
@@ -11107,7 +11077,7 @@
               </a:lnSpc>
             </a:pPr>
             <a:r>
-              <a:rPr lang="en-US" sz="1600"/>
+              <a:rPr lang="en-US" sz="1600" dirty="0"/>
               <a:t>Custom Focal Loss math implemented to resolve severe class imbalances (Dot balls vs Wickets).</a:t>
             </a:r>
           </a:p>
@@ -11122,6 +11092,96 @@
 </file>
 
 <file path=ppt/slides/slide4.xml><?xml version="1.0" encoding="utf-8"?>
+<p:sld xmlns:a="http://schemas.openxmlformats.org/drawingml/2006/main" xmlns:r="http://schemas.openxmlformats.org/officeDocument/2006/relationships" xmlns:p="http://schemas.openxmlformats.org/presentationml/2006/main">
+  <p:cSld>
+    <p:spTree>
+      <p:nvGrpSpPr>
+        <p:cNvPr id="1" name=""/>
+        <p:cNvGrpSpPr/>
+        <p:nvPr/>
+      </p:nvGrpSpPr>
+      <p:grpSpPr>
+        <a:xfrm>
+          <a:off x="0" y="0"/>
+          <a:ext cx="0" cy="0"/>
+          <a:chOff x="0" y="0"/>
+          <a:chExt cx="0" cy="0"/>
+        </a:xfrm>
+      </p:grpSpPr>
+      <p:sp>
+        <p:nvSpPr>
+          <p:cNvPr id="2" name="Title 1">
+            <a:extLst>
+              <a:ext uri="{FF2B5EF4-FFF2-40B4-BE49-F238E27FC236}">
+                <a16:creationId xmlns:a16="http://schemas.microsoft.com/office/drawing/2014/main" id="{6DFA4DF1-BC61-D130-3E87-E72637FB48E9}"/>
+              </a:ext>
+            </a:extLst>
+          </p:cNvPr>
+          <p:cNvSpPr>
+            <a:spLocks noGrp="1"/>
+          </p:cNvSpPr>
+          <p:nvPr>
+            <p:ph type="title"/>
+          </p:nvPr>
+        </p:nvSpPr>
+        <p:spPr/>
+        <p:txBody>
+          <a:bodyPr/>
+          <a:lstStyle/>
+          <a:p>
+            <a:r>
+              <a:rPr lang="en-US" dirty="0"/>
+              <a:t>Model Evaluation</a:t>
+            </a:r>
+          </a:p>
+        </p:txBody>
+      </p:sp>
+      <p:pic>
+        <p:nvPicPr>
+          <p:cNvPr id="5" name="Content Placeholder 4">
+            <a:extLst>
+              <a:ext uri="{FF2B5EF4-FFF2-40B4-BE49-F238E27FC236}">
+                <a16:creationId xmlns:a16="http://schemas.microsoft.com/office/drawing/2014/main" id="{8BD1D4D0-BB76-A40C-5E7B-A6906CF58756}"/>
+              </a:ext>
+            </a:extLst>
+          </p:cNvPr>
+          <p:cNvPicPr>
+            <a:picLocks noGrp="1" noChangeAspect="1"/>
+          </p:cNvPicPr>
+          <p:nvPr>
+            <p:ph idx="1"/>
+          </p:nvPr>
+        </p:nvPicPr>
+        <p:blipFill>
+          <a:blip r:embed="rId2"/>
+          <a:stretch>
+            <a:fillRect/>
+          </a:stretch>
+        </p:blipFill>
+        <p:spPr>
+          <a:xfrm>
+            <a:off x="457200" y="1688816"/>
+            <a:ext cx="8229600" cy="4348731"/>
+          </a:xfrm>
+          <a:prstGeom prst="rect">
+            <a:avLst/>
+          </a:prstGeom>
+        </p:spPr>
+      </p:pic>
+    </p:spTree>
+    <p:extLst>
+      <p:ext uri="{BB962C8B-B14F-4D97-AF65-F5344CB8AC3E}">
+        <p14:creationId xmlns:p14="http://schemas.microsoft.com/office/powerpoint/2010/main" val="1266509953"/>
+      </p:ext>
+    </p:extLst>
+  </p:cSld>
+  <p:clrMapOvr>
+    <a:masterClrMapping/>
+  </p:clrMapOvr>
+</p:sld>
+</file>
+
+<file path=ppt/slides/slide5.xml><?xml version="1.0" encoding="utf-8"?>
 <p:sld xmlns:a="http://schemas.openxmlformats.org/drawingml/2006/main" xmlns:r="http://schemas.openxmlformats.org/officeDocument/2006/relationships" xmlns:p="http://schemas.openxmlformats.org/presentationml/2006/main">
   <p:cSld>
     <p:bg>
@@ -11769,7 +11829,7 @@
 </p:sld>
 </file>
 
-<file path=ppt/slides/slide5.xml><?xml version="1.0" encoding="utf-8"?>
+<file path=ppt/slides/slide6.xml><?xml version="1.0" encoding="utf-8"?>
 <p:sld xmlns:a="http://schemas.openxmlformats.org/drawingml/2006/main" xmlns:r="http://schemas.openxmlformats.org/officeDocument/2006/relationships" xmlns:p="http://schemas.openxmlformats.org/presentationml/2006/main">
   <p:cSld>
     <p:bg>
@@ -12332,35 +12392,46 @@
           <a:lstStyle/>
           <a:p>
             <a:r>
-              <a:rPr lang="en-US" sz="1900"/>
+              <a:rPr lang="en-US" sz="1900" dirty="0"/>
               <a:t>Cost Analysis:</a:t>
             </a:r>
           </a:p>
           <a:p>
             <a:pPr lvl="1"/>
             <a:r>
-              <a:rPr lang="en-US" sz="1900"/>
-              <a:t>100% Open-source stack (Python, Pandas, SQLite) =  Licensing Fees.</a:t>
+              <a:rPr lang="en-US" sz="1900" dirty="0"/>
+              <a:t>100% Open-source stack (Python, Pandas, SQLite) = 0 </a:t>
             </a:r>
           </a:p>
           <a:p>
             <a:pPr lvl="1"/>
             <a:r>
-              <a:rPr lang="en-US" sz="1900"/>
+              <a:rPr lang="en-US" sz="1900" dirty="0"/>
+              <a:t>Licensing Fees.</a:t>
+            </a:r>
+          </a:p>
+          <a:p>
+            <a:pPr lvl="1"/>
+            <a:r>
+              <a:rPr lang="en-US" sz="1900" dirty="0"/>
               <a:t>Cloud Hosting (AWS EC2 / GCP) = ~ / month.</a:t>
             </a:r>
           </a:p>
           <a:p>
             <a:r>
-              <a:rPr lang="en-US" sz="1900"/>
+              <a:rPr lang="en-US" sz="1900" dirty="0"/>
               <a:t>Conclusion:</a:t>
             </a:r>
           </a:p>
           <a:p>
             <a:pPr lvl="1"/>
             <a:r>
-              <a:rPr lang="en-US" sz="1900"/>
-              <a:t>DeepSequence successfully bridges the gap between basic static stats and real-time pressure prediction.</a:t>
+              <a:rPr lang="en-US" sz="1900" dirty="0" err="1"/>
+              <a:t>DeepSequence</a:t>
+            </a:r>
+            <a:r>
+              <a:rPr lang="en-US" sz="1900" dirty="0"/>
+              <a:t> successfully bridges the gap between basic static stats and real-time pressure prediction.</a:t>
             </a:r>
           </a:p>
         </p:txBody>

</xml_diff>